<commit_message>
docs(submission): complete R10 final submission, video production, and manifest package
</commit_message>
<xml_diff>
--- a/deliverables/SentinAI_Guardian_Pitch_Deck.pptx
+++ b/deliverables/SentinAI_Guardian_Pitch_Deck.pptx
@@ -208,7 +208,7 @@
                 <a:solidFill><a:srgbClr val="E5E7EB"/></a:solidFill>
                 <a:latin typeface="Calibri"/>
               </a:rPr>
-              <a:t>Confirmed On-Chain Sepolia Execution: Tx 0xfe315950...88da (Block #11935960 / 0xb620d8)</a:t>
+              <a:t>Confirmed On-Chain Sepolia Execution: Tx 0xfe315950...88da (0.00001 ETH · Block #11935960)</a:t>
             </a:r>
           </a:p>
         </p:txBody>
@@ -1909,7 +1909,7 @@
                 <a:solidFill><a:srgbClr val="E5E7EB"/></a:solidFill>
                 <a:latin typeface="Calibri"/>
               </a:rPr>
-              <a:t>Confirmed Sepolia Transaction: 0xfe315950001536c94f363c6e7b6522eef69a2b874d958544dd91efe5ee8388da</a:t>
+              <a:t>Confirmed Sepolia Tx: 0xfe315950001536c94f363c6e7b6522eef69a2b874d958544dd91efe5ee8388da (0.00001 ETH / 10^13 wei)</a:t>
             </a:r>
           </a:p>
           <a:p>

</xml_diff>